<commit_message>
Fix orchestration card spacing (stacked number+caption frames)
Co-Authored-By: Claude Opus 4.8 <noreply@anthropic.com>
Claude-Session: https://claude.ai/code/session_015GFhuXGmyaJj72KB2tVx2U
</commit_message>
<xml_diff>
--- a/deck/assets/deck_graphics.pptx
+++ b/deck/assets/deck_graphics.pptx
@@ -7281,8 +7281,8 @@
         </p:nvSpPr>
         <p:spPr>
           <a:xfrm>
-            <a:off x="2286000" y="1447800"/>
-            <a:ext cx="3556000" cy="317500"/>
+            <a:off x="2286000" y="1409700"/>
+            <a:ext cx="3556000" cy="279400"/>
           </a:xfrm>
           <a:prstGeom prst="rect">
             <a:avLst/>
@@ -7307,7 +7307,7 @@
               </a:spcAft>
             </a:pPr>
             <a:r>
-              <a:rPr sz="2400" b="1">
+              <a:rPr sz="2300" b="1">
                 <a:solidFill>
                   <a:srgbClr val="F7DD85"/>
                 </a:solidFill>
@@ -7326,8 +7326,8 @@
         </p:nvSpPr>
         <p:spPr>
           <a:xfrm>
-            <a:off x="2286000" y="1854200"/>
-            <a:ext cx="3556000" cy="571500"/>
+            <a:off x="2286000" y="1739900"/>
+            <a:ext cx="3556000" cy="736600"/>
           </a:xfrm>
           <a:prstGeom prst="rect">
             <a:avLst/>
@@ -7352,7 +7352,7 @@
               </a:spcAft>
             </a:pPr>
             <a:r>
-              <a:rPr sz="6000" b="1">
+              <a:rPr sz="4600" b="1">
                 <a:solidFill>
                   <a:srgbClr val="5FB98C"/>
                 </a:solidFill>
@@ -7361,43 +7361,20 @@
               <a:t>100%</a:t>
             </a:r>
           </a:p>
-        </p:txBody>
-      </p:sp>
-      <p:sp>
-        <p:nvSpPr>
-          <p:cNvPr id="8" name="TextBox 7"/>
-          <p:cNvSpPr txBox="1"/>
-          <p:nvPr/>
-        </p:nvSpPr>
-        <p:spPr>
-          <a:xfrm>
-            <a:off x="2286000" y="2463800"/>
-            <a:ext cx="3556000" cy="177800"/>
-          </a:xfrm>
-          <a:prstGeom prst="rect">
-            <a:avLst/>
-          </a:prstGeom>
-          <a:noFill/>
-        </p:spPr>
-        <p:txBody>
-          <a:bodyPr wrap="square" anchor="t" lIns="12700" rIns="12700" tIns="12700" bIns="12700">
-            <a:spAutoFit/>
-          </a:bodyPr>
-          <a:lstStyle/>
           <a:p>
             <a:pPr algn="ctr">
               <a:lnSpc>
                 <a:spcPct val="105000"/>
               </a:lnSpc>
               <a:spcBef>
-                <a:spcPts val="0"/>
-              </a:spcBef>
-              <a:spcAft>
-                <a:spcPts val="100"/>
-              </a:spcAft>
-            </a:pPr>
-            <a:r>
-              <a:rPr sz="1300" b="0">
+                <a:spcPts val="600"/>
+              </a:spcBef>
+              <a:spcAft>
+                <a:spcPts val="100"/>
+              </a:spcAft>
+            </a:pPr>
+            <a:r>
+              <a:rPr sz="1200" b="0">
                 <a:solidFill>
                   <a:srgbClr val="C2C0D6"/>
                 </a:solidFill>
@@ -7410,14 +7387,14 @@
       </p:sp>
       <p:cxnSp>
         <p:nvCxnSpPr>
-          <p:cNvPr id="9" name="Connector 8"/>
+          <p:cNvPr id="8" name="Connector 7"/>
           <p:cNvCxnSpPr/>
           <p:nvPr/>
         </p:nvCxnSpPr>
         <p:spPr>
           <a:xfrm>
-            <a:off x="2603500" y="2743200"/>
-            <a:ext cx="2921000" cy="0"/>
+            <a:off x="2667000" y="2540000"/>
+            <a:ext cx="2794000" cy="0"/>
           </a:xfrm>
           <a:prstGeom prst="line">
             <a:avLst/>
@@ -7445,14 +7422,14 @@
       </p:cxnSp>
       <p:sp>
         <p:nvSpPr>
-          <p:cNvPr id="10" name="TextBox 9"/>
+          <p:cNvPr id="9" name="TextBox 8"/>
           <p:cNvSpPr txBox="1"/>
           <p:nvPr/>
         </p:nvSpPr>
         <p:spPr>
           <a:xfrm>
-            <a:off x="2286000" y="2844800"/>
-            <a:ext cx="3556000" cy="508000"/>
+            <a:off x="2286000" y="2603500"/>
+            <a:ext cx="3556000" cy="736600"/>
           </a:xfrm>
           <a:prstGeom prst="rect">
             <a:avLst/>
@@ -7477,7 +7454,7 @@
               </a:spcAft>
             </a:pPr>
             <a:r>
-              <a:rPr sz="5200" b="1">
+              <a:rPr sz="4400" b="1">
                 <a:solidFill>
                   <a:srgbClr val="F7DD85"/>
                 </a:solidFill>
@@ -7486,43 +7463,20 @@
               <a:t>17</a:t>
             </a:r>
           </a:p>
-        </p:txBody>
-      </p:sp>
-      <p:sp>
-        <p:nvSpPr>
-          <p:cNvPr id="11" name="TextBox 10"/>
-          <p:cNvSpPr txBox="1"/>
-          <p:nvPr/>
-        </p:nvSpPr>
-        <p:spPr>
-          <a:xfrm>
-            <a:off x="2286000" y="3429000"/>
-            <a:ext cx="3556000" cy="177800"/>
-          </a:xfrm>
-          <a:prstGeom prst="rect">
-            <a:avLst/>
-          </a:prstGeom>
-          <a:noFill/>
-        </p:spPr>
-        <p:txBody>
-          <a:bodyPr wrap="square" anchor="t" lIns="12700" rIns="12700" tIns="12700" bIns="12700">
-            <a:spAutoFit/>
-          </a:bodyPr>
-          <a:lstStyle/>
           <a:p>
             <a:pPr algn="ctr">
               <a:lnSpc>
                 <a:spcPct val="105000"/>
               </a:lnSpc>
               <a:spcBef>
-                <a:spcPts val="0"/>
-              </a:spcBef>
-              <a:spcAft>
-                <a:spcPts val="100"/>
-              </a:spcAft>
-            </a:pPr>
-            <a:r>
-              <a:rPr sz="1300" b="0">
+                <a:spcPts val="600"/>
+              </a:spcBef>
+              <a:spcAft>
+                <a:spcPts val="100"/>
+              </a:spcAft>
+            </a:pPr>
+            <a:r>
+              <a:rPr sz="1200" b="0">
                 <a:solidFill>
                   <a:srgbClr val="C2C0D6"/>
                 </a:solidFill>
@@ -7535,13 +7489,13 @@
       </p:sp>
       <p:sp>
         <p:nvSpPr>
-          <p:cNvPr id="12" name="Rounded Rectangle 11"/>
+          <p:cNvPr id="10" name="Rounded Rectangle 9"/>
           <p:cNvSpPr/>
           <p:nvPr/>
         </p:nvSpPr>
         <p:spPr>
           <a:xfrm>
-            <a:off x="3460750" y="3632200"/>
+            <a:off x="3460750" y="3340100"/>
             <a:ext cx="1206500" cy="203200"/>
           </a:xfrm>
           <a:prstGeom prst="roundRect">
@@ -7602,7 +7556,7 @@
       </p:sp>
       <p:sp>
         <p:nvSpPr>
-          <p:cNvPr id="13" name="Rounded Rectangle 12"/>
+          <p:cNvPr id="11" name="Rounded Rectangle 10"/>
           <p:cNvSpPr/>
           <p:nvPr/>
         </p:nvSpPr>
@@ -7650,14 +7604,14 @@
       </p:sp>
       <p:sp>
         <p:nvSpPr>
-          <p:cNvPr id="14" name="TextBox 13"/>
+          <p:cNvPr id="12" name="TextBox 11"/>
           <p:cNvSpPr txBox="1"/>
           <p:nvPr/>
         </p:nvSpPr>
         <p:spPr>
           <a:xfrm>
-            <a:off x="6413500" y="1447800"/>
-            <a:ext cx="3556000" cy="317500"/>
+            <a:off x="6413500" y="1409700"/>
+            <a:ext cx="3556000" cy="279400"/>
           </a:xfrm>
           <a:prstGeom prst="rect">
             <a:avLst/>
@@ -7682,7 +7636,7 @@
               </a:spcAft>
             </a:pPr>
             <a:r>
-              <a:rPr sz="2400" b="1">
+              <a:rPr sz="2300" b="1">
                 <a:solidFill>
                   <a:srgbClr val="C5BEF2"/>
                 </a:solidFill>
@@ -7695,14 +7649,14 @@
       </p:sp>
       <p:sp>
         <p:nvSpPr>
-          <p:cNvPr id="15" name="TextBox 14"/>
+          <p:cNvPr id="13" name="TextBox 12"/>
           <p:cNvSpPr txBox="1"/>
           <p:nvPr/>
         </p:nvSpPr>
         <p:spPr>
           <a:xfrm>
-            <a:off x="6413500" y="1854200"/>
-            <a:ext cx="3556000" cy="571500"/>
+            <a:off x="6413500" y="1739900"/>
+            <a:ext cx="3556000" cy="736600"/>
           </a:xfrm>
           <a:prstGeom prst="rect">
             <a:avLst/>
@@ -7727,7 +7681,7 @@
               </a:spcAft>
             </a:pPr>
             <a:r>
-              <a:rPr sz="6000" b="1">
+              <a:rPr sz="4600" b="1">
                 <a:solidFill>
                   <a:srgbClr val="5FB98C"/>
                 </a:solidFill>
@@ -7736,43 +7690,20 @@
               <a:t>100%</a:t>
             </a:r>
           </a:p>
-        </p:txBody>
-      </p:sp>
-      <p:sp>
-        <p:nvSpPr>
-          <p:cNvPr id="16" name="TextBox 15"/>
-          <p:cNvSpPr txBox="1"/>
-          <p:nvPr/>
-        </p:nvSpPr>
-        <p:spPr>
-          <a:xfrm>
-            <a:off x="6413500" y="2463800"/>
-            <a:ext cx="3556000" cy="177800"/>
-          </a:xfrm>
-          <a:prstGeom prst="rect">
-            <a:avLst/>
-          </a:prstGeom>
-          <a:noFill/>
-        </p:spPr>
-        <p:txBody>
-          <a:bodyPr wrap="square" anchor="t" lIns="12700" rIns="12700" tIns="12700" bIns="12700">
-            <a:spAutoFit/>
-          </a:bodyPr>
-          <a:lstStyle/>
           <a:p>
             <a:pPr algn="ctr">
               <a:lnSpc>
                 <a:spcPct val="105000"/>
               </a:lnSpc>
               <a:spcBef>
-                <a:spcPts val="0"/>
-              </a:spcBef>
-              <a:spcAft>
-                <a:spcPts val="100"/>
-              </a:spcAft>
-            </a:pPr>
-            <a:r>
-              <a:rPr sz="1300" b="0">
+                <a:spcPts val="600"/>
+              </a:spcBef>
+              <a:spcAft>
+                <a:spcPts val="100"/>
+              </a:spcAft>
+            </a:pPr>
+            <a:r>
+              <a:rPr sz="1200" b="0">
                 <a:solidFill>
                   <a:srgbClr val="C2C0D6"/>
                 </a:solidFill>
@@ -7785,14 +7716,14 @@
       </p:sp>
       <p:cxnSp>
         <p:nvCxnSpPr>
-          <p:cNvPr id="17" name="Connector 16"/>
+          <p:cNvPr id="14" name="Connector 13"/>
           <p:cNvCxnSpPr/>
           <p:nvPr/>
         </p:nvCxnSpPr>
         <p:spPr>
           <a:xfrm>
-            <a:off x="6731000" y="2743200"/>
-            <a:ext cx="2921000" cy="0"/>
+            <a:off x="6794500" y="2540000"/>
+            <a:ext cx="2794000" cy="0"/>
           </a:xfrm>
           <a:prstGeom prst="line">
             <a:avLst/>
@@ -7820,14 +7751,14 @@
       </p:cxnSp>
       <p:sp>
         <p:nvSpPr>
-          <p:cNvPr id="18" name="TextBox 17"/>
+          <p:cNvPr id="15" name="TextBox 14"/>
           <p:cNvSpPr txBox="1"/>
           <p:nvPr/>
         </p:nvSpPr>
         <p:spPr>
           <a:xfrm>
-            <a:off x="6413500" y="2844800"/>
-            <a:ext cx="3556000" cy="508000"/>
+            <a:off x="6413500" y="2603500"/>
+            <a:ext cx="3556000" cy="736600"/>
           </a:xfrm>
           <a:prstGeom prst="rect">
             <a:avLst/>
@@ -7852,7 +7783,7 @@
               </a:spcAft>
             </a:pPr>
             <a:r>
-              <a:rPr sz="5200" b="1">
+              <a:rPr sz="4400" b="1">
                 <a:solidFill>
                   <a:srgbClr val="C5BEF2"/>
                 </a:solidFill>
@@ -7861,43 +7792,20 @@
               <a:t>38</a:t>
             </a:r>
           </a:p>
-        </p:txBody>
-      </p:sp>
-      <p:sp>
-        <p:nvSpPr>
-          <p:cNvPr id="19" name="TextBox 18"/>
-          <p:cNvSpPr txBox="1"/>
-          <p:nvPr/>
-        </p:nvSpPr>
-        <p:spPr>
-          <a:xfrm>
-            <a:off x="6413500" y="3429000"/>
-            <a:ext cx="3556000" cy="177800"/>
-          </a:xfrm>
-          <a:prstGeom prst="rect">
-            <a:avLst/>
-          </a:prstGeom>
-          <a:noFill/>
-        </p:spPr>
-        <p:txBody>
-          <a:bodyPr wrap="square" anchor="t" lIns="12700" rIns="12700" tIns="12700" bIns="12700">
-            <a:spAutoFit/>
-          </a:bodyPr>
-          <a:lstStyle/>
           <a:p>
             <a:pPr algn="ctr">
               <a:lnSpc>
                 <a:spcPct val="105000"/>
               </a:lnSpc>
               <a:spcBef>
-                <a:spcPts val="0"/>
-              </a:spcBef>
-              <a:spcAft>
-                <a:spcPts val="100"/>
-              </a:spcAft>
-            </a:pPr>
-            <a:r>
-              <a:rPr sz="1300" b="0">
+                <a:spcPts val="600"/>
+              </a:spcBef>
+              <a:spcAft>
+                <a:spcPts val="100"/>
+              </a:spcAft>
+            </a:pPr>
+            <a:r>
+              <a:rPr sz="1200" b="0">
                 <a:solidFill>
                   <a:srgbClr val="C2C0D6"/>
                 </a:solidFill>
@@ -7910,13 +7818,13 @@
       </p:sp>
       <p:sp>
         <p:nvSpPr>
-          <p:cNvPr id="20" name="Rounded Rectangle 19"/>
+          <p:cNvPr id="16" name="Rounded Rectangle 15"/>
           <p:cNvSpPr/>
           <p:nvPr/>
         </p:nvSpPr>
         <p:spPr>
           <a:xfrm>
-            <a:off x="7588250" y="3632200"/>
+            <a:off x="7588250" y="3340100"/>
             <a:ext cx="1206500" cy="203200"/>
           </a:xfrm>
           <a:prstGeom prst="roundRect">
@@ -7977,13 +7885,13 @@
       </p:sp>
       <p:sp>
         <p:nvSpPr>
-          <p:cNvPr id="21" name="TextBox 20"/>
+          <p:cNvPr id="17" name="TextBox 16"/>
           <p:cNvSpPr txBox="1"/>
           <p:nvPr/>
         </p:nvSpPr>
         <p:spPr>
           <a:xfrm>
-            <a:off x="5842000" y="1841500"/>
+            <a:off x="5842000" y="1892300"/>
             <a:ext cx="508000" cy="381000"/>
           </a:xfrm>
           <a:prstGeom prst="rect">
@@ -8022,13 +7930,13 @@
       </p:sp>
       <p:sp>
         <p:nvSpPr>
-          <p:cNvPr id="22" name="TextBox 21"/>
+          <p:cNvPr id="18" name="TextBox 17"/>
           <p:cNvSpPr txBox="1"/>
           <p:nvPr/>
         </p:nvSpPr>
         <p:spPr>
           <a:xfrm>
-            <a:off x="5842000" y="2870200"/>
+            <a:off x="5842000" y="2717800"/>
             <a:ext cx="508000" cy="254000"/>
           </a:xfrm>
           <a:prstGeom prst="rect">
@@ -8067,7 +7975,7 @@
       </p:sp>
       <p:sp>
         <p:nvSpPr>
-          <p:cNvPr id="23" name="Rounded Rectangle 22"/>
+          <p:cNvPr id="19" name="Rounded Rectangle 18"/>
           <p:cNvSpPr/>
           <p:nvPr/>
         </p:nvSpPr>

</xml_diff>

<commit_message>
Orchestration: drop foot pills, move linear/branching label under title
Co-Authored-By: Claude Opus 4.8 <noreply@anthropic.com>
Claude-Session: https://claude.ai/code/session_015GFhuXGmyaJj72KB2tVx2U
</commit_message>
<xml_diff>
--- a/deck/assets/deck_graphics.pptx
+++ b/deck/assets/deck_graphics.pptx
@@ -7281,8 +7281,8 @@
         </p:nvSpPr>
         <p:spPr>
           <a:xfrm>
-            <a:off x="2286000" y="1409700"/>
-            <a:ext cx="3556000" cy="279400"/>
+            <a:off x="2286000" y="1422400"/>
+            <a:ext cx="3556000" cy="419100"/>
           </a:xfrm>
           <a:prstGeom prst="rect">
             <a:avLst/>
@@ -7316,6 +7316,28 @@
               <a:t>Hand-written loop</a:t>
             </a:r>
           </a:p>
+          <a:p>
+            <a:pPr algn="ctr">
+              <a:lnSpc>
+                <a:spcPct val="105000"/>
+              </a:lnSpc>
+              <a:spcBef>
+                <a:spcPts val="400"/>
+              </a:spcBef>
+              <a:spcAft>
+                <a:spcPts val="100"/>
+              </a:spcAft>
+            </a:pPr>
+            <a:r>
+              <a:rPr sz="1200" b="0">
+                <a:solidFill>
+                  <a:srgbClr val="C2C0D6"/>
+                </a:solidFill>
+                <a:latin typeface="Poppins"/>
+              </a:rPr>
+              <a:t>linear planner</a:t>
+            </a:r>
+          </a:p>
         </p:txBody>
       </p:sp>
       <p:sp>
@@ -7326,8 +7348,8 @@
         </p:nvSpPr>
         <p:spPr>
           <a:xfrm>
-            <a:off x="2286000" y="1739900"/>
-            <a:ext cx="3556000" cy="736600"/>
+            <a:off x="2286000" y="1943100"/>
+            <a:ext cx="3556000" cy="698500"/>
           </a:xfrm>
           <a:prstGeom prst="rect">
             <a:avLst/>
@@ -7393,7 +7415,7 @@
         </p:nvCxnSpPr>
         <p:spPr>
           <a:xfrm>
-            <a:off x="2667000" y="2540000"/>
+            <a:off x="2667000" y="2730500"/>
             <a:ext cx="2794000" cy="0"/>
           </a:xfrm>
           <a:prstGeom prst="line">
@@ -7428,8 +7450,8 @@
         </p:nvSpPr>
         <p:spPr>
           <a:xfrm>
-            <a:off x="2286000" y="2603500"/>
-            <a:ext cx="3556000" cy="736600"/>
+            <a:off x="2286000" y="2794000"/>
+            <a:ext cx="3556000" cy="698500"/>
           </a:xfrm>
           <a:prstGeom prst="rect">
             <a:avLst/>
@@ -7454,7 +7476,7 @@
               </a:spcAft>
             </a:pPr>
             <a:r>
-              <a:rPr sz="4400" b="1">
+              <a:rPr sz="4600" b="1">
                 <a:solidFill>
                   <a:srgbClr val="F7DD85"/>
                 </a:solidFill>
@@ -7490,73 +7512,6 @@
       <p:sp>
         <p:nvSpPr>
           <p:cNvPr id="10" name="Rounded Rectangle 9"/>
-          <p:cNvSpPr/>
-          <p:nvPr/>
-        </p:nvSpPr>
-        <p:spPr>
-          <a:xfrm>
-            <a:off x="3460750" y="3340100"/>
-            <a:ext cx="1206500" cy="203200"/>
-          </a:xfrm>
-          <a:prstGeom prst="roundRect">
-            <a:avLst>
-              <a:gd name="adj" fmla="val 50000"/>
-            </a:avLst>
-          </a:prstGeom>
-          <a:solidFill>
-            <a:srgbClr val="232239"/>
-          </a:solidFill>
-          <a:ln w="12700">
-            <a:solidFill>
-              <a:srgbClr val="F0C84C"/>
-            </a:solidFill>
-          </a:ln>
-          <a:effectLst/>
-        </p:spPr>
-        <p:style>
-          <a:lnRef idx="1">
-            <a:schemeClr val="accent1"/>
-          </a:lnRef>
-          <a:fillRef idx="3">
-            <a:schemeClr val="accent1"/>
-          </a:fillRef>
-          <a:effectRef idx="2">
-            <a:schemeClr val="accent1"/>
-          </a:effectRef>
-          <a:fontRef idx="minor">
-            <a:schemeClr val="lt1"/>
-          </a:fontRef>
-        </p:style>
-        <p:txBody>
-          <a:bodyPr rtlCol="0" anchor="ctr" wrap="square" lIns="88900" rIns="63500" tIns="50800" bIns="38100"/>
-          <a:lstStyle/>
-          <a:p>
-            <a:pPr algn="ctr">
-              <a:lnSpc>
-                <a:spcPct val="105000"/>
-              </a:lnSpc>
-              <a:spcBef>
-                <a:spcPts val="0"/>
-              </a:spcBef>
-              <a:spcAft>
-                <a:spcPts val="100"/>
-              </a:spcAft>
-            </a:pPr>
-            <a:r>
-              <a:rPr sz="1200" b="0">
-                <a:solidFill>
-                  <a:srgbClr val="F7DD85"/>
-                </a:solidFill>
-                <a:latin typeface="Poppins"/>
-              </a:rPr>
-              <a:t>linear planner</a:t>
-            </a:r>
-          </a:p>
-        </p:txBody>
-      </p:sp>
-      <p:sp>
-        <p:nvSpPr>
-          <p:cNvPr id="11" name="Rounded Rectangle 10"/>
           <p:cNvSpPr/>
           <p:nvPr/>
         </p:nvSpPr>
@@ -7604,14 +7559,81 @@
       </p:sp>
       <p:sp>
         <p:nvSpPr>
+          <p:cNvPr id="11" name="TextBox 10"/>
+          <p:cNvSpPr txBox="1"/>
+          <p:nvPr/>
+        </p:nvSpPr>
+        <p:spPr>
+          <a:xfrm>
+            <a:off x="6413500" y="1422400"/>
+            <a:ext cx="3556000" cy="419100"/>
+          </a:xfrm>
+          <a:prstGeom prst="rect">
+            <a:avLst/>
+          </a:prstGeom>
+          <a:noFill/>
+        </p:spPr>
+        <p:txBody>
+          <a:bodyPr wrap="square" anchor="t" lIns="12700" rIns="12700" tIns="12700" bIns="12700">
+            <a:spAutoFit/>
+          </a:bodyPr>
+          <a:lstStyle/>
+          <a:p>
+            <a:pPr algn="ctr">
+              <a:lnSpc>
+                <a:spcPct val="105000"/>
+              </a:lnSpc>
+              <a:spcBef>
+                <a:spcPts val="0"/>
+              </a:spcBef>
+              <a:spcAft>
+                <a:spcPts val="100"/>
+              </a:spcAft>
+            </a:pPr>
+            <a:r>
+              <a:rPr sz="2300" b="1">
+                <a:solidFill>
+                  <a:srgbClr val="C5BEF2"/>
+                </a:solidFill>
+                <a:latin typeface="Poppins"/>
+              </a:rPr>
+              <a:t>LangGraph</a:t>
+            </a:r>
+          </a:p>
+          <a:p>
+            <a:pPr algn="ctr">
+              <a:lnSpc>
+                <a:spcPct val="105000"/>
+              </a:lnSpc>
+              <a:spcBef>
+                <a:spcPts val="400"/>
+              </a:spcBef>
+              <a:spcAft>
+                <a:spcPts val="100"/>
+              </a:spcAft>
+            </a:pPr>
+            <a:r>
+              <a:rPr sz="1200" b="0">
+                <a:solidFill>
+                  <a:srgbClr val="C2C0D6"/>
+                </a:solidFill>
+                <a:latin typeface="Poppins"/>
+              </a:rPr>
+              <a:t>branching + HITL</a:t>
+            </a:r>
+          </a:p>
+        </p:txBody>
+      </p:sp>
+      <p:sp>
+        <p:nvSpPr>
           <p:cNvPr id="12" name="TextBox 11"/>
           <p:cNvSpPr txBox="1"/>
           <p:nvPr/>
         </p:nvSpPr>
         <p:spPr>
           <a:xfrm>
-            <a:off x="6413500" y="1409700"/>
-            <a:ext cx="3556000" cy="279400"/>
+            <a:off x="6413500" y="1943100"/>
+            <a:ext cx="3556000" cy="698500"/>
           </a:xfrm>
           <a:prstGeom prst="rect">
             <a:avLst/>
@@ -7636,51 +7658,6 @@
               </a:spcAft>
             </a:pPr>
             <a:r>
-              <a:rPr sz="2300" b="1">
-                <a:solidFill>
-                  <a:srgbClr val="C5BEF2"/>
-                </a:solidFill>
-                <a:latin typeface="Poppins"/>
-              </a:rPr>
-              <a:t>LangGraph</a:t>
-            </a:r>
-          </a:p>
-        </p:txBody>
-      </p:sp>
-      <p:sp>
-        <p:nvSpPr>
-          <p:cNvPr id="13" name="TextBox 12"/>
-          <p:cNvSpPr txBox="1"/>
-          <p:nvPr/>
-        </p:nvSpPr>
-        <p:spPr>
-          <a:xfrm>
-            <a:off x="6413500" y="1739900"/>
-            <a:ext cx="3556000" cy="736600"/>
-          </a:xfrm>
-          <a:prstGeom prst="rect">
-            <a:avLst/>
-          </a:prstGeom>
-          <a:noFill/>
-        </p:spPr>
-        <p:txBody>
-          <a:bodyPr wrap="square" anchor="t" lIns="12700" rIns="12700" tIns="12700" bIns="12700">
-            <a:spAutoFit/>
-          </a:bodyPr>
-          <a:lstStyle/>
-          <a:p>
-            <a:pPr algn="ctr">
-              <a:lnSpc>
-                <a:spcPct val="105000"/>
-              </a:lnSpc>
-              <a:spcBef>
-                <a:spcPts val="0"/>
-              </a:spcBef>
-              <a:spcAft>
-                <a:spcPts val="100"/>
-              </a:spcAft>
-            </a:pPr>
-            <a:r>
               <a:rPr sz="4600" b="1">
                 <a:solidFill>
                   <a:srgbClr val="5FB98C"/>
@@ -7716,13 +7693,13 @@
       </p:sp>
       <p:cxnSp>
         <p:nvCxnSpPr>
-          <p:cNvPr id="14" name="Connector 13"/>
+          <p:cNvPr id="13" name="Connector 12"/>
           <p:cNvCxnSpPr/>
           <p:nvPr/>
         </p:nvCxnSpPr>
         <p:spPr>
           <a:xfrm>
-            <a:off x="6794500" y="2540000"/>
+            <a:off x="6794500" y="2730500"/>
             <a:ext cx="2794000" cy="0"/>
           </a:xfrm>
           <a:prstGeom prst="line">
@@ -7751,14 +7728,81 @@
       </p:cxnSp>
       <p:sp>
         <p:nvSpPr>
+          <p:cNvPr id="14" name="TextBox 13"/>
+          <p:cNvSpPr txBox="1"/>
+          <p:nvPr/>
+        </p:nvSpPr>
+        <p:spPr>
+          <a:xfrm>
+            <a:off x="6413500" y="2794000"/>
+            <a:ext cx="3556000" cy="698500"/>
+          </a:xfrm>
+          <a:prstGeom prst="rect">
+            <a:avLst/>
+          </a:prstGeom>
+          <a:noFill/>
+        </p:spPr>
+        <p:txBody>
+          <a:bodyPr wrap="square" anchor="t" lIns="12700" rIns="12700" tIns="12700" bIns="12700">
+            <a:spAutoFit/>
+          </a:bodyPr>
+          <a:lstStyle/>
+          <a:p>
+            <a:pPr algn="ctr">
+              <a:lnSpc>
+                <a:spcPct val="105000"/>
+              </a:lnSpc>
+              <a:spcBef>
+                <a:spcPts val="0"/>
+              </a:spcBef>
+              <a:spcAft>
+                <a:spcPts val="100"/>
+              </a:spcAft>
+            </a:pPr>
+            <a:r>
+              <a:rPr sz="4600" b="1">
+                <a:solidFill>
+                  <a:srgbClr val="C5BEF2"/>
+                </a:solidFill>
+                <a:latin typeface="Roboto Mono"/>
+              </a:rPr>
+              <a:t>38</a:t>
+            </a:r>
+          </a:p>
+          <a:p>
+            <a:pPr algn="ctr">
+              <a:lnSpc>
+                <a:spcPct val="105000"/>
+              </a:lnSpc>
+              <a:spcBef>
+                <a:spcPts val="600"/>
+              </a:spcBef>
+              <a:spcAft>
+                <a:spcPts val="100"/>
+              </a:spcAft>
+            </a:pPr>
+            <a:r>
+              <a:rPr sz="1200" b="0">
+                <a:solidFill>
+                  <a:srgbClr val="C2C0D6"/>
+                </a:solidFill>
+                <a:latin typeface="Poppins"/>
+              </a:rPr>
+              <a:t>lines (2.2×)</a:t>
+            </a:r>
+          </a:p>
+        </p:txBody>
+      </p:sp>
+      <p:sp>
+        <p:nvSpPr>
           <p:cNvPr id="15" name="TextBox 14"/>
           <p:cNvSpPr txBox="1"/>
           <p:nvPr/>
         </p:nvSpPr>
         <p:spPr>
           <a:xfrm>
-            <a:off x="6413500" y="2603500"/>
-            <a:ext cx="3556000" cy="736600"/>
+            <a:off x="5842000" y="2235200"/>
+            <a:ext cx="508000" cy="381000"/>
           </a:xfrm>
           <a:prstGeom prst="rect">
             <a:avLst/>
@@ -7783,116 +7827,27 @@
               </a:spcAft>
             </a:pPr>
             <a:r>
-              <a:rPr sz="4400" b="1">
-                <a:solidFill>
-                  <a:srgbClr val="C5BEF2"/>
-                </a:solidFill>
-                <a:latin typeface="Roboto Mono"/>
-              </a:rPr>
-              <a:t>38</a:t>
-            </a:r>
-          </a:p>
-          <a:p>
-            <a:pPr algn="ctr">
-              <a:lnSpc>
-                <a:spcPct val="105000"/>
-              </a:lnSpc>
-              <a:spcBef>
-                <a:spcPts val="600"/>
-              </a:spcBef>
-              <a:spcAft>
-                <a:spcPts val="100"/>
-              </a:spcAft>
-            </a:pPr>
-            <a:r>
-              <a:rPr sz="1200" b="0">
+              <a:rPr sz="4000" b="1">
                 <a:solidFill>
                   <a:srgbClr val="C2C0D6"/>
                 </a:solidFill>
                 <a:latin typeface="Poppins"/>
               </a:rPr>
-              <a:t>lines (2.2×)</a:t>
-            </a:r>
-          </a:p>
-        </p:txBody>
-      </p:sp>
-      <p:sp>
-        <p:nvSpPr>
-          <p:cNvPr id="16" name="Rounded Rectangle 15"/>
-          <p:cNvSpPr/>
-          <p:nvPr/>
-        </p:nvSpPr>
-        <p:spPr>
-          <a:xfrm>
-            <a:off x="7588250" y="3340100"/>
-            <a:ext cx="1206500" cy="203200"/>
-          </a:xfrm>
-          <a:prstGeom prst="roundRect">
-            <a:avLst>
-              <a:gd name="adj" fmla="val 50000"/>
-            </a:avLst>
-          </a:prstGeom>
-          <a:solidFill>
-            <a:srgbClr val="232239"/>
-          </a:solidFill>
-          <a:ln w="12700">
-            <a:solidFill>
-              <a:srgbClr val="A89FE6"/>
-            </a:solidFill>
-          </a:ln>
-          <a:effectLst/>
-        </p:spPr>
-        <p:style>
-          <a:lnRef idx="1">
-            <a:schemeClr val="accent1"/>
-          </a:lnRef>
-          <a:fillRef idx="3">
-            <a:schemeClr val="accent1"/>
-          </a:fillRef>
-          <a:effectRef idx="2">
-            <a:schemeClr val="accent1"/>
-          </a:effectRef>
-          <a:fontRef idx="minor">
-            <a:schemeClr val="lt1"/>
-          </a:fontRef>
-        </p:style>
-        <p:txBody>
-          <a:bodyPr rtlCol="0" anchor="ctr" wrap="square" lIns="88900" rIns="63500" tIns="50800" bIns="38100"/>
-          <a:lstStyle/>
-          <a:p>
-            <a:pPr algn="ctr">
-              <a:lnSpc>
-                <a:spcPct val="105000"/>
-              </a:lnSpc>
-              <a:spcBef>
-                <a:spcPts val="0"/>
-              </a:spcBef>
-              <a:spcAft>
-                <a:spcPts val="100"/>
-              </a:spcAft>
-            </a:pPr>
-            <a:r>
-              <a:rPr sz="1200" b="0">
-                <a:solidFill>
-                  <a:srgbClr val="C5BEF2"/>
-                </a:solidFill>
-                <a:latin typeface="Poppins"/>
-              </a:rPr>
-              <a:t>branching + HITL</a:t>
-            </a:r>
-          </a:p>
-        </p:txBody>
-      </p:sp>
-      <p:sp>
-        <p:nvSpPr>
-          <p:cNvPr id="17" name="TextBox 16"/>
+              <a:t>=</a:t>
+            </a:r>
+          </a:p>
+        </p:txBody>
+      </p:sp>
+      <p:sp>
+        <p:nvSpPr>
+          <p:cNvPr id="16" name="TextBox 15"/>
           <p:cNvSpPr txBox="1"/>
           <p:nvPr/>
         </p:nvSpPr>
         <p:spPr>
           <a:xfrm>
-            <a:off x="5842000" y="1892300"/>
-            <a:ext cx="508000" cy="381000"/>
+            <a:off x="5842000" y="3086100"/>
+            <a:ext cx="508000" cy="254000"/>
           </a:xfrm>
           <a:prstGeom prst="rect">
             <a:avLst/>
@@ -7917,57 +7872,12 @@
               </a:spcAft>
             </a:pPr>
             <a:r>
-              <a:rPr sz="4000" b="1">
+              <a:rPr sz="2200" b="1">
                 <a:solidFill>
                   <a:srgbClr val="C2C0D6"/>
                 </a:solidFill>
                 <a:latin typeface="Poppins"/>
               </a:rPr>
-              <a:t>=</a:t>
-            </a:r>
-          </a:p>
-        </p:txBody>
-      </p:sp>
-      <p:sp>
-        <p:nvSpPr>
-          <p:cNvPr id="18" name="TextBox 17"/>
-          <p:cNvSpPr txBox="1"/>
-          <p:nvPr/>
-        </p:nvSpPr>
-        <p:spPr>
-          <a:xfrm>
-            <a:off x="5842000" y="2717800"/>
-            <a:ext cx="508000" cy="254000"/>
-          </a:xfrm>
-          <a:prstGeom prst="rect">
-            <a:avLst/>
-          </a:prstGeom>
-          <a:noFill/>
-        </p:spPr>
-        <p:txBody>
-          <a:bodyPr wrap="square" anchor="t" lIns="12700" rIns="12700" tIns="12700" bIns="12700">
-            <a:spAutoFit/>
-          </a:bodyPr>
-          <a:lstStyle/>
-          <a:p>
-            <a:pPr algn="ctr">
-              <a:lnSpc>
-                <a:spcPct val="105000"/>
-              </a:lnSpc>
-              <a:spcBef>
-                <a:spcPts val="0"/>
-              </a:spcBef>
-              <a:spcAft>
-                <a:spcPts val="100"/>
-              </a:spcAft>
-            </a:pPr>
-            <a:r>
-              <a:rPr sz="2200" b="1">
-                <a:solidFill>
-                  <a:srgbClr val="C2C0D6"/>
-                </a:solidFill>
-                <a:latin typeface="Poppins"/>
-              </a:rPr>
               <a:t>vs</a:t>
             </a:r>
           </a:p>
@@ -7975,7 +7885,7 @@
       </p:sp>
       <p:sp>
         <p:nvSpPr>
-          <p:cNvPr id="19" name="Rounded Rectangle 18"/>
+          <p:cNvPr id="17" name="Rounded Rectangle 16"/>
           <p:cNvSpPr/>
           <p:nvPr/>
         </p:nvSpPr>

</xml_diff>